<commit_message>
Update Final Project Presentation.pptx
Presentation update
</commit_message>
<xml_diff>
--- a/Presentations/Final Project Presentation.pptx
+++ b/Presentations/Final Project Presentation.pptx
@@ -311,7 +311,7 @@
           <a:p>
             <a:fld id="{5BCAD085-E8A6-8845-BD4E-CB4CCA059FC4}" type="datetimeFigureOut">
               <a:rPr lang="en-US" smtClean="0"/>
-              <a:t>8/10/2026</a:t>
+              <a:t>8/12/2026</a:t>
             </a:fld>
             <a:endParaRPr lang="en-US"/>
           </a:p>
@@ -479,7 +479,7 @@
           <a:p>
             <a:fld id="{5BCAD085-E8A6-8845-BD4E-CB4CCA059FC4}" type="datetimeFigureOut">
               <a:rPr lang="en-US" smtClean="0"/>
-              <a:t>8/10/2026</a:t>
+              <a:t>8/12/2026</a:t>
             </a:fld>
             <a:endParaRPr lang="en-US"/>
           </a:p>
@@ -657,7 +657,7 @@
           <a:p>
             <a:fld id="{5BCAD085-E8A6-8845-BD4E-CB4CCA059FC4}" type="datetimeFigureOut">
               <a:rPr lang="en-US" smtClean="0"/>
-              <a:t>8/10/2026</a:t>
+              <a:t>8/12/2026</a:t>
             </a:fld>
             <a:endParaRPr lang="en-US"/>
           </a:p>
@@ -825,7 +825,7 @@
           <a:p>
             <a:fld id="{5BCAD085-E8A6-8845-BD4E-CB4CCA059FC4}" type="datetimeFigureOut">
               <a:rPr lang="en-US" smtClean="0"/>
-              <a:t>8/10/2026</a:t>
+              <a:t>8/12/2026</a:t>
             </a:fld>
             <a:endParaRPr lang="en-US"/>
           </a:p>
@@ -1070,7 +1070,7 @@
           <a:p>
             <a:fld id="{5BCAD085-E8A6-8845-BD4E-CB4CCA059FC4}" type="datetimeFigureOut">
               <a:rPr lang="en-US" smtClean="0"/>
-              <a:t>8/10/2026</a:t>
+              <a:t>8/12/2026</a:t>
             </a:fld>
             <a:endParaRPr lang="en-US"/>
           </a:p>
@@ -1355,7 +1355,7 @@
           <a:p>
             <a:fld id="{5BCAD085-E8A6-8845-BD4E-CB4CCA059FC4}" type="datetimeFigureOut">
               <a:rPr lang="en-US" smtClean="0"/>
-              <a:t>8/10/2026</a:t>
+              <a:t>8/12/2026</a:t>
             </a:fld>
             <a:endParaRPr lang="en-US"/>
           </a:p>
@@ -1774,7 +1774,7 @@
           <a:p>
             <a:fld id="{5BCAD085-E8A6-8845-BD4E-CB4CCA059FC4}" type="datetimeFigureOut">
               <a:rPr lang="en-US" smtClean="0"/>
-              <a:t>8/10/2026</a:t>
+              <a:t>8/12/2026</a:t>
             </a:fld>
             <a:endParaRPr lang="en-US"/>
           </a:p>
@@ -1891,7 +1891,7 @@
           <a:p>
             <a:fld id="{5BCAD085-E8A6-8845-BD4E-CB4CCA059FC4}" type="datetimeFigureOut">
               <a:rPr lang="en-US" smtClean="0"/>
-              <a:t>8/10/2026</a:t>
+              <a:t>8/12/2026</a:t>
             </a:fld>
             <a:endParaRPr lang="en-US"/>
           </a:p>
@@ -1986,7 +1986,7 @@
           <a:p>
             <a:fld id="{5BCAD085-E8A6-8845-BD4E-CB4CCA059FC4}" type="datetimeFigureOut">
               <a:rPr lang="en-US" smtClean="0"/>
-              <a:t>8/10/2026</a:t>
+              <a:t>8/12/2026</a:t>
             </a:fld>
             <a:endParaRPr lang="en-US"/>
           </a:p>
@@ -2261,7 +2261,7 @@
           <a:p>
             <a:fld id="{5BCAD085-E8A6-8845-BD4E-CB4CCA059FC4}" type="datetimeFigureOut">
               <a:rPr lang="en-US" smtClean="0"/>
-              <a:t>8/10/2026</a:t>
+              <a:t>8/12/2026</a:t>
             </a:fld>
             <a:endParaRPr lang="en-US"/>
           </a:p>
@@ -2513,7 +2513,7 @@
           <a:p>
             <a:fld id="{5BCAD085-E8A6-8845-BD4E-CB4CCA059FC4}" type="datetimeFigureOut">
               <a:rPr lang="en-US" smtClean="0"/>
-              <a:t>8/10/2026</a:t>
+              <a:t>8/12/2026</a:t>
             </a:fld>
             <a:endParaRPr lang="en-US"/>
           </a:p>
@@ -2724,7 +2724,7 @@
           <a:p>
             <a:fld id="{5BCAD085-E8A6-8845-BD4E-CB4CCA059FC4}" type="datetimeFigureOut">
               <a:rPr lang="en-US" smtClean="0"/>
-              <a:t>8/10/2026</a:t>
+              <a:t>8/12/2026</a:t>
             </a:fld>
             <a:endParaRPr lang="en-US"/>
           </a:p>
@@ -5351,7 +5351,7 @@
         </p:nvSpPr>
         <p:spPr>
           <a:xfrm>
-            <a:off x="756009" y="2050497"/>
+            <a:off x="756009" y="2232839"/>
             <a:ext cx="2898648" cy="307777"/>
           </a:xfrm>
           <a:prstGeom prst="rect">
@@ -5503,7 +5503,7 @@
         </p:nvSpPr>
         <p:spPr>
           <a:xfrm>
-            <a:off x="4457647" y="2232839"/>
+            <a:off x="4568163" y="2232839"/>
             <a:ext cx="2898648" cy="307777"/>
           </a:xfrm>
           <a:prstGeom prst="rect">
@@ -5553,7 +5553,7 @@
         </p:nvSpPr>
         <p:spPr>
           <a:xfrm>
-            <a:off x="8466609" y="2179370"/>
+            <a:off x="8403336" y="2066544"/>
             <a:ext cx="502920" cy="109728"/>
           </a:xfrm>
           <a:prstGeom prst="roundRect">
@@ -5827,7 +5827,7 @@
         </p:nvSpPr>
         <p:spPr>
           <a:xfrm>
-            <a:off x="4457647" y="4833643"/>
+            <a:off x="4568163" y="4866684"/>
             <a:ext cx="2898648" cy="307777"/>
           </a:xfrm>
           <a:prstGeom prst="rect">
@@ -6015,7 +6015,7 @@
         </p:blipFill>
         <p:spPr>
           <a:xfrm>
-            <a:off x="8466609" y="4513572"/>
+            <a:off x="8403336" y="4562726"/>
             <a:ext cx="591363" cy="195089"/>
           </a:xfrm>
           <a:prstGeom prst="rect">
@@ -6190,7 +6190,7 @@
         <p:spPr>
           <a:xfrm>
             <a:off x="777240" y="1828799"/>
-            <a:ext cx="3017520" cy="1335023"/>
+            <a:ext cx="3017520" cy="1371601"/>
           </a:xfrm>
           <a:prstGeom prst="roundRect">
             <a:avLst/>
@@ -6279,7 +6279,7 @@
         </p:nvSpPr>
         <p:spPr>
           <a:xfrm>
-            <a:off x="996695" y="2212848"/>
+            <a:off x="978408" y="2171699"/>
             <a:ext cx="2578608" cy="411480"/>
           </a:xfrm>
           <a:prstGeom prst="rect">
@@ -6298,7 +6298,7 @@
           <a:p>
             <a:pPr algn="l"/>
             <a:r>
-              <a:rPr sz="1700" b="1">
+              <a:rPr sz="1700" b="1" dirty="0">
                 <a:solidFill>
                   <a:srgbClr val="182745"/>
                 </a:solidFill>
@@ -6446,7 +6446,7 @@
         </p:nvSpPr>
         <p:spPr>
           <a:xfrm>
-            <a:off x="996695" y="3675888"/>
+            <a:off x="978408" y="3630168"/>
             <a:ext cx="2578608" cy="411480"/>
           </a:xfrm>
           <a:prstGeom prst="rect">
@@ -6465,7 +6465,7 @@
           <a:p>
             <a:pPr algn="l"/>
             <a:r>
-              <a:rPr sz="1700" b="1">
+              <a:rPr sz="1700" b="1" dirty="0">
                 <a:solidFill>
                   <a:srgbClr val="182745"/>
                 </a:solidFill>
@@ -6503,7 +6503,7 @@
           <a:p>
             <a:pPr algn="l"/>
             <a:r>
-              <a:rPr sz="1300" b="0">
+              <a:rPr sz="1300" b="0" dirty="0">
                 <a:solidFill>
                   <a:srgbClr val="1E2739"/>
                 </a:solidFill>
@@ -6522,8 +6522,8 @@
         </p:nvSpPr>
         <p:spPr>
           <a:xfrm>
-            <a:off x="777240" y="4572000"/>
-            <a:ext cx="3017520" cy="1355834"/>
+            <a:off x="777240" y="4571999"/>
+            <a:ext cx="3017520" cy="1433945"/>
           </a:xfrm>
           <a:prstGeom prst="roundRect">
             <a:avLst/>
@@ -6612,7 +6612,7 @@
         </p:nvSpPr>
         <p:spPr>
           <a:xfrm>
-            <a:off x="996695" y="4956048"/>
+            <a:off x="996695" y="4911159"/>
             <a:ext cx="2578608" cy="411480"/>
           </a:xfrm>
           <a:prstGeom prst="rect">
@@ -11410,8 +11410,8 @@
         </p:nvSpPr>
         <p:spPr>
           <a:xfrm>
-            <a:off x="1005840" y="4343400"/>
-            <a:ext cx="6446520" cy="1298448"/>
+            <a:off x="1005840" y="4343399"/>
+            <a:ext cx="6446520" cy="1402773"/>
           </a:xfrm>
           <a:prstGeom prst="roundRect">
             <a:avLst/>
@@ -11563,8 +11563,23 @@
                 </a:solidFill>
                 <a:latin typeface="Aptos"/>
               </a:rPr>
-              <a:t>Keep TF-IDF as the transparent foundation, then add scientific ranking signals when lexical overlap alone was not enough.</a:t>
-            </a:r>
+              <a:t>Keep TF-IDF as the transparent foundation, </a:t>
+            </a:r>
+            <a:r>
+              <a:rPr lang="en-US" sz="1300" b="0" dirty="0">
+                <a:solidFill>
+                  <a:srgbClr val="1E2739"/>
+                </a:solidFill>
+                <a:latin typeface="Aptos"/>
+              </a:rPr>
+              <a:t>With keywords for project ranking. </a:t>
+            </a:r>
+            <a:endParaRPr sz="1300" b="0" dirty="0">
+              <a:solidFill>
+                <a:srgbClr val="1E2739"/>
+              </a:solidFill>
+              <a:latin typeface="Aptos"/>
+            </a:endParaRPr>
           </a:p>
         </p:txBody>
       </p:sp>
@@ -12557,8 +12572,8 @@
         </p:nvSpPr>
         <p:spPr>
           <a:xfrm>
-            <a:off x="6537960" y="2583180"/>
-            <a:ext cx="2167128" cy="2423160"/>
+            <a:off x="6702552" y="3105834"/>
+            <a:ext cx="2167128" cy="646331"/>
           </a:xfrm>
           <a:prstGeom prst="rect">
             <a:avLst/>
@@ -12576,15 +12591,20 @@
           <a:p>
             <a:pPr algn="l"/>
             <a:r>
-              <a:rPr sz="1200" b="0" dirty="0">
+              <a:rPr lang="en-US" sz="1200" b="0" dirty="0">
                 <a:solidFill>
                   <a:srgbClr val="1E2739"/>
                 </a:solidFill>
                 <a:latin typeface="Aptos"/>
               </a:rPr>
-              <a:t>Compare the current interpretable TF-IDF hybrid with embeddings or lexical + semantic retrieval.
-Test improvement rather than assume complexity is better.</a:t>
-            </a:r>
+              <a:t>Improve the model with sentence embeddings as an added feature.</a:t>
+            </a:r>
+            <a:endParaRPr sz="1200" b="0" dirty="0">
+              <a:solidFill>
+                <a:srgbClr val="1E2739"/>
+              </a:solidFill>
+              <a:latin typeface="Aptos"/>
+            </a:endParaRPr>
           </a:p>
         </p:txBody>
       </p:sp>

</xml_diff>